<commit_message>
People admin: per-row + bulk delete, 10 per page
- Row trash icon and tick + 'Delete selected' bulk action, both with a
  confirm. Admin rows are never selectable/deletable.
- New admin_delete_users(uuid[]) (security-definer, is_admin gated) that
  refuses to delete the caller or any admin; cascades to user data.
- API route /api/admin/delete-users validates payload and gates on admin.
- Pagination reduced from 15 to 10 rows per page.

Co-Authored-By: Claude Opus 4.8 <noreply@anthropic.com>
</commit_message>
<xml_diff>
--- a/collateral/ExpoLead-CRM-Positioning-v3.pptx
+++ b/collateral/ExpoLead-CRM-Positioning-v3.pptx
@@ -508,7 +508,7 @@
           <a:p>
             <a:r>
               <a:rPr lang="en-US" dirty="0"/>
-              <a:t>Opening frame: ExpoLead is not a CRM competitor. It sits alongside whatever CRM the prospect already runs (Salesforce, HubSpot, Zoho, Bigin, Pipedrive, Odoo) and owns only the exhibition layer.</a:t>
+              <a:t>Opening frame: ExpoLead is not a CRM competitor and is not sold as a CRM integration. It runs the exhibition and owns only the exhibition layer; the user keeps whatever CRM they already run and takes the clean lead into it. We do not have CRM integrations today.</a:t>
             </a:r>
             <a:endParaRPr lang="en-US" dirty="0"/>
           </a:p>
@@ -1799,7 +1799,7 @@
                 <a:ea typeface="Calibri" pitchFamily="34" charset="-122"/>
                 <a:cs typeface="Calibri" pitchFamily="34" charset="-120"/>
               </a:rPr>
-              <a:t>WORKS ALONGSIDE THE CRM YOU ALREADY USE</a:t>
+              <a:t>NO RIP AND REPLACE</a:t>
             </a:r>
             <a:endParaRPr lang="en-US" sz="1050" dirty="0"/>
           </a:p>
@@ -1807,57 +1807,50 @@
       </p:sp>
       <p:sp>
         <p:nvSpPr>
-          <p:cNvPr id="12" name="Shape 10"/>
-          <p:cNvSpPr/>
-          <p:nvPr/>
-        </p:nvSpPr>
-        <p:spPr>
-          <a:xfrm>
-            <a:off x="502920" y="5577840"/>
-            <a:ext cx="1197864" cy="384048"/>
-          </a:xfrm>
-          <a:prstGeom prst="roundRect">
-            <a:avLst>
-              <a:gd name="adj" fmla="val 23810"/>
-            </a:avLst>
-          </a:prstGeom>
-          <a:solidFill>
-            <a:srgbClr val="1E293B"/>
-          </a:solidFill>
-          <a:ln w="12700">
-            <a:solidFill>
-              <a:srgbClr val="334155"/>
-            </a:solidFill>
-            <a:prstDash val="solid"/>
-          </a:ln>
-        </p:spPr>
-      </p:sp>
-      <p:sp>
-        <p:nvSpPr>
-          <p:cNvPr id="13" name="Text 11"/>
-          <p:cNvSpPr/>
-          <p:nvPr/>
-        </p:nvSpPr>
-        <p:spPr>
-          <a:xfrm>
-            <a:off x="502920" y="5577840"/>
-            <a:ext cx="1197864" cy="384048"/>
-          </a:xfrm>
-          <a:prstGeom prst="rect">
-            <a:avLst/>
-          </a:prstGeom>
-          <a:noFill/>
-          <a:ln/>
-        </p:spPr>
-        <p:txBody>
-          <a:bodyPr wrap="square" lIns="0" tIns="0" rIns="0" bIns="0" rtlCol="0" anchor="ctr"/>
-          <a:lstStyle/>
-          <a:p>
-            <a:pPr algn="ctr" indent="0" marL="0">
-              <a:buNone/>
-            </a:pPr>
-            <a:r>
-              <a:rPr lang="en-US" sz="1200" b="1" dirty="0">
+          <p:cNvPr id="12" name="Text 10"/>
+          <p:cNvSpPr/>
+          <p:nvPr/>
+        </p:nvSpPr>
+        <p:spPr>
+          <a:xfrm>
+            <a:off x="502920" y="5559552"/>
+            <a:ext cx="9601200" cy="457200"/>
+          </a:xfrm>
+          <a:prstGeom prst="rect">
+            <a:avLst/>
+          </a:prstGeom>
+          <a:noFill/>
+          <a:ln/>
+        </p:spPr>
+        <p:txBody>
+          <a:bodyPr wrap="square" lIns="0" tIns="0" rIns="0" bIns="0" rtlCol="0" anchor="t"/>
+          <a:lstStyle/>
+          <a:p>
+            <a:pPr algn="l" indent="0" marL="0">
+              <a:lnSpc>
+                <a:spcPct val="112000"/>
+              </a:lnSpc>
+              <a:buNone/>
+            </a:pPr>
+            <a:r>
+              <a:rPr lang="en-US" sz="1450" b="1" dirty="0">
+                <a:solidFill>
+                  <a:srgbClr val="FFFFFF"/>
+                </a:solidFill>
+                <a:latin typeface="Calibri" pitchFamily="34" charset="0"/>
+                <a:ea typeface="Calibri" pitchFamily="34" charset="-122"/>
+                <a:cs typeface="Calibri" pitchFamily="34" charset="-120"/>
+              </a:rPr>
+              <a:t>Keep the CRM you already use. </a:t>
+            </a:r>
+            <a:pPr algn="l" indent="0" marL="0">
+              <a:lnSpc>
+                <a:spcPct val="112000"/>
+              </a:lnSpc>
+              <a:buNone/>
+            </a:pPr>
+            <a:r>
+              <a:rPr lang="en-US" sz="1450" dirty="0">
                 <a:solidFill>
                   <a:srgbClr val="CBD5E1"/>
                 </a:solidFill>
@@ -1865,339 +1858,9 @@
                 <a:ea typeface="Calibri" pitchFamily="34" charset="-122"/>
                 <a:cs typeface="Calibri" pitchFamily="34" charset="-120"/>
               </a:rPr>
-              <a:t>Salesforce</a:t>
-            </a:r>
-            <a:endParaRPr lang="en-US" sz="1200" dirty="0"/>
-          </a:p>
-        </p:txBody>
-      </p:sp>
-      <p:sp>
-        <p:nvSpPr>
-          <p:cNvPr id="14" name="Shape 12"/>
-          <p:cNvSpPr/>
-          <p:nvPr/>
-        </p:nvSpPr>
-        <p:spPr>
-          <a:xfrm>
-            <a:off x="1847088" y="5577840"/>
-            <a:ext cx="937260" cy="384048"/>
-          </a:xfrm>
-          <a:prstGeom prst="roundRect">
-            <a:avLst>
-              <a:gd name="adj" fmla="val 23810"/>
-            </a:avLst>
-          </a:prstGeom>
-          <a:solidFill>
-            <a:srgbClr val="1E293B"/>
-          </a:solidFill>
-          <a:ln w="12700">
-            <a:solidFill>
-              <a:srgbClr val="334155"/>
-            </a:solidFill>
-            <a:prstDash val="solid"/>
-          </a:ln>
-        </p:spPr>
-      </p:sp>
-      <p:sp>
-        <p:nvSpPr>
-          <p:cNvPr id="15" name="Text 13"/>
-          <p:cNvSpPr/>
-          <p:nvPr/>
-        </p:nvSpPr>
-        <p:spPr>
-          <a:xfrm>
-            <a:off x="1847088" y="5577840"/>
-            <a:ext cx="937260" cy="384048"/>
-          </a:xfrm>
-          <a:prstGeom prst="rect">
-            <a:avLst/>
-          </a:prstGeom>
-          <a:noFill/>
-          <a:ln/>
-        </p:spPr>
-        <p:txBody>
-          <a:bodyPr wrap="square" lIns="0" tIns="0" rIns="0" bIns="0" rtlCol="0" anchor="ctr"/>
-          <a:lstStyle/>
-          <a:p>
-            <a:pPr algn="ctr" indent="0" marL="0">
-              <a:buNone/>
-            </a:pPr>
-            <a:r>
-              <a:rPr lang="en-US" sz="1200" b="1" dirty="0">
-                <a:solidFill>
-                  <a:srgbClr val="CBD5E1"/>
-                </a:solidFill>
-                <a:latin typeface="Calibri" pitchFamily="34" charset="0"/>
-                <a:ea typeface="Calibri" pitchFamily="34" charset="-122"/>
-                <a:cs typeface="Calibri" pitchFamily="34" charset="-120"/>
-              </a:rPr>
-              <a:t>HubSpot</a:t>
-            </a:r>
-            <a:endParaRPr lang="en-US" sz="1200" dirty="0"/>
-          </a:p>
-        </p:txBody>
-      </p:sp>
-      <p:sp>
-        <p:nvSpPr>
-          <p:cNvPr id="16" name="Shape 14"/>
-          <p:cNvSpPr/>
-          <p:nvPr/>
-        </p:nvSpPr>
-        <p:spPr>
-          <a:xfrm>
-            <a:off x="2930652" y="5577840"/>
-            <a:ext cx="1024128" cy="384048"/>
-          </a:xfrm>
-          <a:prstGeom prst="roundRect">
-            <a:avLst>
-              <a:gd name="adj" fmla="val 23810"/>
-            </a:avLst>
-          </a:prstGeom>
-          <a:solidFill>
-            <a:srgbClr val="1E293B"/>
-          </a:solidFill>
-          <a:ln w="12700">
-            <a:solidFill>
-              <a:srgbClr val="334155"/>
-            </a:solidFill>
-            <a:prstDash val="solid"/>
-          </a:ln>
-        </p:spPr>
-      </p:sp>
-      <p:sp>
-        <p:nvSpPr>
-          <p:cNvPr id="17" name="Text 15"/>
-          <p:cNvSpPr/>
-          <p:nvPr/>
-        </p:nvSpPr>
-        <p:spPr>
-          <a:xfrm>
-            <a:off x="2930652" y="5577840"/>
-            <a:ext cx="1024128" cy="384048"/>
-          </a:xfrm>
-          <a:prstGeom prst="rect">
-            <a:avLst/>
-          </a:prstGeom>
-          <a:noFill/>
-          <a:ln/>
-        </p:spPr>
-        <p:txBody>
-          <a:bodyPr wrap="square" lIns="0" tIns="0" rIns="0" bIns="0" rtlCol="0" anchor="ctr"/>
-          <a:lstStyle/>
-          <a:p>
-            <a:pPr algn="ctr" indent="0" marL="0">
-              <a:buNone/>
-            </a:pPr>
-            <a:r>
-              <a:rPr lang="en-US" sz="1200" b="1" dirty="0">
-                <a:solidFill>
-                  <a:srgbClr val="CBD5E1"/>
-                </a:solidFill>
-                <a:latin typeface="Calibri" pitchFamily="34" charset="0"/>
-                <a:ea typeface="Calibri" pitchFamily="34" charset="-122"/>
-                <a:cs typeface="Calibri" pitchFamily="34" charset="-120"/>
-              </a:rPr>
-              <a:t>Zoho CRM</a:t>
-            </a:r>
-            <a:endParaRPr lang="en-US" sz="1200" dirty="0"/>
-          </a:p>
-        </p:txBody>
-      </p:sp>
-      <p:sp>
-        <p:nvSpPr>
-          <p:cNvPr id="18" name="Shape 16"/>
-          <p:cNvSpPr/>
-          <p:nvPr/>
-        </p:nvSpPr>
-        <p:spPr>
-          <a:xfrm>
-            <a:off x="4101084" y="5577840"/>
-            <a:ext cx="763524" cy="384048"/>
-          </a:xfrm>
-          <a:prstGeom prst="roundRect">
-            <a:avLst>
-              <a:gd name="adj" fmla="val 23810"/>
-            </a:avLst>
-          </a:prstGeom>
-          <a:solidFill>
-            <a:srgbClr val="1E293B"/>
-          </a:solidFill>
-          <a:ln w="12700">
-            <a:solidFill>
-              <a:srgbClr val="334155"/>
-            </a:solidFill>
-            <a:prstDash val="solid"/>
-          </a:ln>
-        </p:spPr>
-      </p:sp>
-      <p:sp>
-        <p:nvSpPr>
-          <p:cNvPr id="19" name="Text 17"/>
-          <p:cNvSpPr/>
-          <p:nvPr/>
-        </p:nvSpPr>
-        <p:spPr>
-          <a:xfrm>
-            <a:off x="4101084" y="5577840"/>
-            <a:ext cx="763524" cy="384048"/>
-          </a:xfrm>
-          <a:prstGeom prst="rect">
-            <a:avLst/>
-          </a:prstGeom>
-          <a:noFill/>
-          <a:ln/>
-        </p:spPr>
-        <p:txBody>
-          <a:bodyPr wrap="square" lIns="0" tIns="0" rIns="0" bIns="0" rtlCol="0" anchor="ctr"/>
-          <a:lstStyle/>
-          <a:p>
-            <a:pPr algn="ctr" indent="0" marL="0">
-              <a:buNone/>
-            </a:pPr>
-            <a:r>
-              <a:rPr lang="en-US" sz="1200" b="1" dirty="0">
-                <a:solidFill>
-                  <a:srgbClr val="CBD5E1"/>
-                </a:solidFill>
-                <a:latin typeface="Calibri" pitchFamily="34" charset="0"/>
-                <a:ea typeface="Calibri" pitchFamily="34" charset="-122"/>
-                <a:cs typeface="Calibri" pitchFamily="34" charset="-120"/>
-              </a:rPr>
-              <a:t>Bigin</a:t>
-            </a:r>
-            <a:endParaRPr lang="en-US" sz="1200" dirty="0"/>
-          </a:p>
-        </p:txBody>
-      </p:sp>
-      <p:sp>
-        <p:nvSpPr>
-          <p:cNvPr id="20" name="Shape 18"/>
-          <p:cNvSpPr/>
-          <p:nvPr/>
-        </p:nvSpPr>
-        <p:spPr>
-          <a:xfrm>
-            <a:off x="5010912" y="5577840"/>
-            <a:ext cx="1110996" cy="384048"/>
-          </a:xfrm>
-          <a:prstGeom prst="roundRect">
-            <a:avLst>
-              <a:gd name="adj" fmla="val 23810"/>
-            </a:avLst>
-          </a:prstGeom>
-          <a:solidFill>
-            <a:srgbClr val="1E293B"/>
-          </a:solidFill>
-          <a:ln w="12700">
-            <a:solidFill>
-              <a:srgbClr val="334155"/>
-            </a:solidFill>
-            <a:prstDash val="solid"/>
-          </a:ln>
-        </p:spPr>
-      </p:sp>
-      <p:sp>
-        <p:nvSpPr>
-          <p:cNvPr id="21" name="Text 19"/>
-          <p:cNvSpPr/>
-          <p:nvPr/>
-        </p:nvSpPr>
-        <p:spPr>
-          <a:xfrm>
-            <a:off x="5010912" y="5577840"/>
-            <a:ext cx="1110996" cy="384048"/>
-          </a:xfrm>
-          <a:prstGeom prst="rect">
-            <a:avLst/>
-          </a:prstGeom>
-          <a:noFill/>
-          <a:ln/>
-        </p:spPr>
-        <p:txBody>
-          <a:bodyPr wrap="square" lIns="0" tIns="0" rIns="0" bIns="0" rtlCol="0" anchor="ctr"/>
-          <a:lstStyle/>
-          <a:p>
-            <a:pPr algn="ctr" indent="0" marL="0">
-              <a:buNone/>
-            </a:pPr>
-            <a:r>
-              <a:rPr lang="en-US" sz="1200" b="1" dirty="0">
-                <a:solidFill>
-                  <a:srgbClr val="CBD5E1"/>
-                </a:solidFill>
-                <a:latin typeface="Calibri" pitchFamily="34" charset="0"/>
-                <a:ea typeface="Calibri" pitchFamily="34" charset="-122"/>
-                <a:cs typeface="Calibri" pitchFamily="34" charset="-120"/>
-              </a:rPr>
-              <a:t>Pipedrive</a:t>
-            </a:r>
-            <a:endParaRPr lang="en-US" sz="1200" dirty="0"/>
-          </a:p>
-        </p:txBody>
-      </p:sp>
-      <p:sp>
-        <p:nvSpPr>
-          <p:cNvPr id="22" name="Shape 20"/>
-          <p:cNvSpPr/>
-          <p:nvPr/>
-        </p:nvSpPr>
-        <p:spPr>
-          <a:xfrm>
-            <a:off x="6268212" y="5577840"/>
-            <a:ext cx="676656" cy="384048"/>
-          </a:xfrm>
-          <a:prstGeom prst="roundRect">
-            <a:avLst>
-              <a:gd name="adj" fmla="val 23810"/>
-            </a:avLst>
-          </a:prstGeom>
-          <a:solidFill>
-            <a:srgbClr val="1E293B"/>
-          </a:solidFill>
-          <a:ln w="12700">
-            <a:solidFill>
-              <a:srgbClr val="334155"/>
-            </a:solidFill>
-            <a:prstDash val="solid"/>
-          </a:ln>
-        </p:spPr>
-      </p:sp>
-      <p:sp>
-        <p:nvSpPr>
-          <p:cNvPr id="23" name="Text 21"/>
-          <p:cNvSpPr/>
-          <p:nvPr/>
-        </p:nvSpPr>
-        <p:spPr>
-          <a:xfrm>
-            <a:off x="6268212" y="5577840"/>
-            <a:ext cx="676656" cy="384048"/>
-          </a:xfrm>
-          <a:prstGeom prst="rect">
-            <a:avLst/>
-          </a:prstGeom>
-          <a:noFill/>
-          <a:ln/>
-        </p:spPr>
-        <p:txBody>
-          <a:bodyPr wrap="square" lIns="0" tIns="0" rIns="0" bIns="0" rtlCol="0" anchor="ctr"/>
-          <a:lstStyle/>
-          <a:p>
-            <a:pPr algn="ctr" indent="0" marL="0">
-              <a:buNone/>
-            </a:pPr>
-            <a:r>
-              <a:rPr lang="en-US" sz="1200" b="1" dirty="0">
-                <a:solidFill>
-                  <a:srgbClr val="CBD5E1"/>
-                </a:solidFill>
-                <a:latin typeface="Calibri" pitchFamily="34" charset="0"/>
-                <a:ea typeface="Calibri" pitchFamily="34" charset="-122"/>
-                <a:cs typeface="Calibri" pitchFamily="34" charset="-120"/>
-              </a:rPr>
-              <a:t>Odoo</a:t>
-            </a:r>
-            <a:endParaRPr lang="en-US" sz="1200" dirty="0"/>
+              <a:t>ExpoLead owns the exhibition, then you take the clean lead into your CRM.</a:t>
+            </a:r>
+            <a:endParaRPr lang="en-US" sz="1450" dirty="0"/>
           </a:p>
         </p:txBody>
       </p:sp>
@@ -7325,7 +6988,7 @@
                 <a:ea typeface="Calibri" pitchFamily="34" charset="-122"/>
                 <a:cs typeface="Calibri" pitchFamily="34" charset="-120"/>
               </a:rPr>
-              <a:t>A CRM begins with the finished lead. Everything before that clean record, the plan, the floor and the follow-through, is the ExpoLead job. It works alongside the CRM you already use.</a:t>
+              <a:t>A CRM begins with the finished lead. Everything before that clean record, the plan, the floor and the follow-through, is the ExpoLead job. You then take that clean lead into whatever CRM you already use.</a:t>
             </a:r>
             <a:endParaRPr lang="en-US" sz="1250" dirty="0"/>
           </a:p>
@@ -10717,7 +10380,7 @@
                 <a:ea typeface="Calibri" pitchFamily="34" charset="-122"/>
                 <a:cs typeface="Calibri" pitchFamily="34" charset="-120"/>
               </a:rPr>
-              <a:t>WORKS ALONGSIDE  ·  SALESFORCE  ·  HUBSPOT  ·  ZOHO  ·  BIGIN  ·  PIPEDRIVE  ·  ODOO</a:t>
+              <a:t>NO RIP AND REPLACE  ·  KEEP THE CRM YOU ALREADY USE</a:t>
             </a:r>
             <a:endParaRPr lang="en-US" sz="1050" dirty="0"/>
           </a:p>

</xml_diff>